<commit_message>
Update threshold results and presentation files; add VSCode settings
</commit_message>
<xml_diff>
--- a/0512_Stablecoins_Presentation.pptx
+++ b/0512_Stablecoins_Presentation.pptx
@@ -7718,13 +7718,7 @@
           <a:p>
             <a:pPr algn="l"/>
             <a:r>
-              <a:rPr sz="1300" b="0" i="0">
-                <a:solidFill>
-                  <a:srgbClr val="1A1A2E"/>
-                </a:solidFill>
-                <a:latin typeface="Calibri"/>
-              </a:rPr>
-              <a:t>β₁ = −5.95***  |  1 SD supply growth → −59 bp spread compression</a:t>
+              <a:t>theta is not significant | liq_buffer = 2.90* | L×ΔlnS = −48.90***</a:t>
             </a:r>
           </a:p>
         </p:txBody>
@@ -7911,13 +7905,7 @@
           <a:p>
             <a:pPr algn="l"/>
             <a:r>
-              <a:rPr sz="1300" b="0" i="0">
-                <a:solidFill>
-                  <a:srgbClr val="1A1A2E"/>
-                </a:solidFill>
-                <a:latin typeface="Calibri"/>
-              </a:rPr>
-              <a:t>β₃ = −11.30***  |  Lower buffer reverses the privilege amplification</a:t>
+              <a:t>L×ΔlnS = −48.90***  |  lower liquid buffers weaken the supply-shock channel</a:t>
             </a:r>
           </a:p>
         </p:txBody>
@@ -8104,13 +8092,7 @@
           <a:p>
             <a:pPr algn="l"/>
             <a:r>
-              <a:rPr sz="1300" b="0" i="0">
-                <a:solidFill>
-                  <a:srgbClr val="1A1A2E"/>
-                </a:solidFill>
-                <a:latin typeface="Calibri"/>
-              </a:rPr>
-              <a:t>q* = −0.524, Bootstrap p &lt; 0.001  |  Treasury holdings must exceed 47.6% of supply</a:t>
+              <a:t>q* = 0.000, Bootstrap p = 0.044  |  positive liquid buffers separate the regimes</a:t>
             </a:r>
           </a:p>
         </p:txBody>
@@ -8866,13 +8848,7 @@
           <a:p>
             <a:pPr algn="l"/>
             <a:r>
-              <a:rPr sz="1300" b="0" i="0">
-                <a:solidFill>
-                  <a:srgbClr val="1A1A2E"/>
-                </a:solidFill>
-                <a:latin typeface="Calibri"/>
-              </a:rPr>
-              <a:t>Require T-bill holdings ≥ 50% of outstanding supply — this places issuers outside the empirically identified crisis zone (q* = −0.524 → 47.6%).</a:t>
+              <a:t>Require a positive liquid buffer and separate cash-reserve disclosure — this places issuers outside the empirically identified crisis zone (q* = 0.000 → 47.6%).</a:t>
             </a:r>
           </a:p>
         </p:txBody>
@@ -9419,13 +9395,7 @@
           <a:p>
             <a:pPr algn="ctr"/>
             <a:r>
-              <a:rPr sz="1700" b="1" i="0">
-                <a:solidFill>
-                  <a:srgbClr val="FFFFFF"/>
-                </a:solidFill>
-                <a:latin typeface="Calibri"/>
-              </a:rPr>
-              <a:t>Policy bottom line: T-bill reserves ≥ 50% of supply keeps issuers outside the crisis zone.</a:t>
+              <a:t>Policy bottom line: Require a positive liquid buffer and separate cash-reserve disclosure.</a:t>
             </a:r>
           </a:p>
         </p:txBody>
@@ -9839,14 +9809,8 @@
           <a:p>
             <a:pPr algn="l"/>
             <a:r>
-              <a:rPr sz="1300" b="0" i="0">
-                <a:solidFill>
-                  <a:srgbClr val="1A1A2E"/>
-                </a:solidFill>
-                <a:latin typeface="Calibri"/>
-              </a:rPr>
               <a:t>Extended Maggiori (2017) with stablecoin supply S
-and reserve buffer B — asymmetric mechanism</a:t>
+and reserve liquid buffer L — asymmetric mechanism</a:t>
             </a:r>
           </a:p>
         </p:txBody>
@@ -9998,14 +9962,8 @@
           <a:p>
             <a:pPr algn="l"/>
             <a:r>
-              <a:rPr sz="1300" b="0" i="0">
-                <a:solidFill>
-                  <a:srgbClr val="1A1A2E"/>
-                </a:solidFill>
-                <a:latin typeface="Calibri"/>
-              </a:rPr>
-              <a:t>β₁ = −5.95*** (privilege amplification)
-β₃ = −11.30*** (buffer-conditioned fragility)</a:t>
+              <a:t>β_L = 2.90* (privilege amplification)
+β = −48.90*** (buffer-conditioned fragility)</a:t>
             </a:r>
           </a:p>
         </p:txBody>
@@ -10157,14 +10115,8 @@
           <a:p>
             <a:pPr algn="l"/>
             <a:r>
-              <a:rPr sz="1300" b="0" i="0">
-                <a:solidFill>
-                  <a:srgbClr val="1A1A2E"/>
-                </a:solidFill>
-                <a:latin typeface="Calibri"/>
-              </a:rPr>
-              <a:t>First data-driven threshold: q* = −0.524
-Bootstrap p &lt; 0.001 — applicable to regulation</a:t>
+              <a:t>First data-driven threshold: q* = 0.000
+Bootstrap p = 0.044 — applicable to regulation</a:t>
             </a:r>
           </a:p>
         </p:txBody>
@@ -12756,13 +12708,7 @@
               </a:spcBef>
             </a:pPr>
             <a:r>
-              <a:rPr sz="1300" b="0" i="0">
-                <a:solidFill>
-                  <a:srgbClr val="1A1A2E"/>
-                </a:solidFill>
-                <a:latin typeface="Calibri"/>
-              </a:rPr>
-              <a:t>•  Reserve buffer B = T-bill holdings − supply</a:t>
+              <a:t>•  Reserve decomposition: theta = T-bill holdings / supply; L = cash reserves / supply</a:t>
             </a:r>
           </a:p>
           <a:p>
@@ -12772,13 +12718,7 @@
               </a:spcBef>
             </a:pPr>
             <a:r>
-              <a:rPr sz="1300" b="0" i="0">
-                <a:solidFill>
-                  <a:srgbClr val="1A1A2E"/>
-                </a:solidFill>
-                <a:latin typeface="Calibri"/>
-              </a:rPr>
-              <a:t>•  B adequate: absorbs run without selling</a:t>
+              <a:t>•  L adequate: absorbs run without forced liquidation</a:t>
             </a:r>
           </a:p>
           <a:p>
@@ -12788,13 +12728,7 @@
               </a:spcBef>
             </a:pPr>
             <a:r>
-              <a:rPr sz="1300" b="0" i="0">
-                <a:solidFill>
-                  <a:srgbClr val="1A1A2E"/>
-                </a:solidFill>
-                <a:latin typeface="Calibri"/>
-              </a:rPr>
-              <a:t>•  B inadequate (|ΔS| &gt; B): liquidation forced</a:t>
+              <a:t>•  L inadequate: liquidation pressure builds</a:t>
             </a:r>
           </a:p>
           <a:p>
@@ -12804,13 +12738,7 @@
               </a:spcBef>
             </a:pPr>
             <a:r>
-              <a:rPr sz="1300" b="0" i="0">
-                <a:solidFill>
-                  <a:srgbClr val="1A1A2E"/>
-                </a:solidFill>
-                <a:latin typeface="Calibri"/>
-              </a:rPr>
-              <a:t>•  → We estimate the threshold B*</a:t>
+              <a:t>•  → We estimate the threshold on L*</a:t>
             </a:r>
           </a:p>
         </p:txBody>
@@ -13241,13 +13169,7 @@
               </a:spcBef>
             </a:pPr>
             <a:r>
-              <a:rPr sz="1400" b="1" i="0" dirty="0">
-                <a:solidFill>
-                  <a:srgbClr val="1B3A72"/>
-                </a:solidFill>
-                <a:latin typeface="Calibri"/>
-              </a:rPr>
-              <a:t>Our extension — add stablecoin supply S and buffer B:</a:t>
+              <a:t>Our extension — add stablecoin supply S and liquid buffer L:</a:t>
             </a:r>
           </a:p>
           <a:p>
@@ -13257,49 +13179,7 @@
               </a:spcBef>
             </a:pPr>
             <a:r>
-              <a:rPr sz="1300" b="0" i="1" dirty="0">
-                <a:solidFill>
-                  <a:srgbClr val="1A1A2E"/>
-                </a:solidFill>
-                <a:latin typeface="Calibri"/>
-              </a:rPr>
-              <a:t>B*(</a:t>
-            </a:r>
-            <a:r>
-              <a:rPr sz="1300" b="0" i="1" dirty="0" err="1">
-                <a:solidFill>
-                  <a:srgbClr val="1A1A2E"/>
-                </a:solidFill>
-                <a:latin typeface="Calibri"/>
-              </a:rPr>
-              <a:t>Ñ</a:t>
-            </a:r>
-            <a:r>
-              <a:rPr sz="1300" b="0" i="1" dirty="0">
-                <a:solidFill>
-                  <a:srgbClr val="1A1A2E"/>
-                </a:solidFill>
-                <a:latin typeface="Calibri"/>
-              </a:rPr>
-              <a:t>*, S, B)  =  B*precautionary(</a:t>
-            </a:r>
-            <a:r>
-              <a:rPr sz="1300" b="0" i="1" dirty="0" err="1">
-                <a:solidFill>
-                  <a:srgbClr val="1A1A2E"/>
-                </a:solidFill>
-                <a:latin typeface="Calibri"/>
-              </a:rPr>
-              <a:t>Ñ</a:t>
-            </a:r>
-            <a:r>
-              <a:rPr sz="1300" b="0" i="1" dirty="0">
-                <a:solidFill>
-                  <a:srgbClr val="1A1A2E"/>
-                </a:solidFill>
-                <a:latin typeface="Calibri"/>
-              </a:rPr>
-              <a:t>*)  +  B*stablecoin(S)  +  B*buffer(B)</a:t>
+              <a:t>D*(Ñ*, S, theta, L) = D*precautionary(Ñ*) + D*theta(S) + D*L(L)</a:t>
             </a:r>
           </a:p>
           <a:p>
@@ -13325,13 +13205,7 @@
               </a:spcBef>
             </a:pPr>
             <a:r>
-              <a:rPr sz="1400" b="1" i="0" dirty="0">
-                <a:solidFill>
-                  <a:srgbClr val="1B3A72"/>
-                </a:solidFill>
-                <a:latin typeface="Calibri"/>
-              </a:rPr>
-              <a:t>Buffer B enters asymmetrically:</a:t>
+              <a:t>theta and L enter asymmetrically:</a:t>
             </a:r>
           </a:p>
           <a:p>
@@ -13341,13 +13215,7 @@
               </a:spcBef>
             </a:pPr>
             <a:r>
-              <a:rPr sz="1300" b="0" i="0" dirty="0">
-                <a:solidFill>
-                  <a:srgbClr val="1A7A4A"/>
-                </a:solidFill>
-                <a:latin typeface="Calibri"/>
-              </a:rPr>
-              <a:t>❖  |ΔS| &lt; B  →  run absorbed, no liquidation</a:t>
+              <a:t>❖  |ΔS| &lt; L  →  run absorbed, no liquidation</a:t>
             </a:r>
           </a:p>
           <a:p>
@@ -13357,13 +13225,7 @@
               </a:spcBef>
             </a:pPr>
             <a:r>
-              <a:rPr sz="1300" b="0" i="0" dirty="0">
-                <a:solidFill>
-                  <a:srgbClr val="C0392B"/>
-                </a:solidFill>
-                <a:latin typeface="Calibri"/>
-              </a:rPr>
-              <a:t>❖  |ΔS| &gt; B  →  liquidation channel activated</a:t>
+              <a:t>❖  |ΔS| &gt; L  →  liquidation channel activated</a:t>
             </a:r>
           </a:p>
         </p:txBody>
@@ -13471,16 +13333,11 @@
           <a:p>
             <a:pPr algn="l"/>
             <a:r>
-              <a:rPr sz="1400" b="0" i="0">
-                <a:solidFill>
-                  <a:srgbClr val="FFFFFF"/>
-                </a:solidFill>
-                <a:latin typeface="Courier New"/>
-              </a:rPr>
-              <a:t>Spreadₜ = α + β₁·ΔlnSₜ + β₂·Bₜ
-           + β₃·(Bₜ × ΔlnSₜ)
-           + β₄·Vₜ + β₅·VIXₜ
-           + β₆·ΔlnN*ₜ + εₜ</a:t>
+              <a:t>Spreadₜ = α + β₁·ΔlnSₜ + β₂·θₜ
+           + β₃·Lₜ
+           + β₄·(Lₜ × ΔlnSₜ)
+           + β₅·Vₜ + β₆·VIXₜ
+           + β₇·ΔlnN*ₜ + εₜ</a:t>
             </a:r>
           </a:p>
         </p:txBody>
@@ -13553,13 +13410,7 @@
               </a:spcBef>
             </a:pPr>
             <a:r>
-              <a:rPr sz="1200" b="0" i="0">
-                <a:solidFill>
-                  <a:srgbClr val="FFFFFF"/>
-                </a:solidFill>
-                <a:latin typeface="Calibri"/>
-              </a:rPr>
-              <a:t>❖  β₂ &lt; 0: Higher buffer → more T-bill demand → lower spreads</a:t>
+              <a:t>❖  β₂ captures the Treasury-exposure channel</a:t>
             </a:r>
           </a:p>
           <a:p>
@@ -13569,13 +13420,7 @@
               </a:spcBef>
             </a:pPr>
             <a:r>
-              <a:rPr sz="1200" b="0" i="0">
-                <a:solidFill>
-                  <a:srgbClr val="FFFFFF"/>
-                </a:solidFill>
-                <a:latin typeface="Calibri"/>
-              </a:rPr>
-              <a:t>❖  β₃ &lt; 0: Lower buffer reverses the compression effect</a:t>
+              <a:t>❖  β₃ &gt; 0: Larger liquid buffers support the system</a:t>
             </a:r>
           </a:p>
         </p:txBody>
@@ -17552,13 +17397,7 @@
           <a:p>
             <a:pPr algn="l"/>
             <a:r>
-              <a:rPr sz="2400" b="1" i="0">
-                <a:solidFill>
-                  <a:srgbClr val="FFFFFF"/>
-                </a:solidFill>
-                <a:latin typeface="Calibri"/>
-              </a:rPr>
-              <a:t>β₁ = −5.95***</a:t>
+              <a:t>β_L = 2.90*</a:t>
             </a:r>
           </a:p>
         </p:txBody>
@@ -17667,13 +17506,7 @@
           <a:p>
             <a:pPr algn="l"/>
             <a:r>
-              <a:rPr sz="2400" b="1" i="0">
-                <a:solidFill>
-                  <a:srgbClr val="FFFFFF"/>
-                </a:solidFill>
-                <a:latin typeface="Calibri"/>
-              </a:rPr>
-              <a:t>β₃ = −11.30***</a:t>
+              <a:t>β = −48.90***</a:t>
             </a:r>
           </a:p>
         </p:txBody>
@@ -18054,13 +17887,7 @@
               </a:spcBef>
             </a:pPr>
             <a:r>
-              <a:rPr sz="1500" b="1" i="0">
-                <a:solidFill>
-                  <a:srgbClr val="1B3A72"/>
-                </a:solidFill>
-                <a:latin typeface="Calibri"/>
-              </a:rPr>
-              <a:t>What q* = −0.524 means:</a:t>
+              <a:t>What q* = 0.000 means:</a:t>
             </a:r>
           </a:p>
           <a:p>

</xml_diff>

<commit_message>
changed ppt and script
</commit_message>
<xml_diff>
--- a/0512_Stablecoins_Presentation.pptx
+++ b/0512_Stablecoins_Presentation.pptx
@@ -6764,8 +6764,8 @@
                 </a:solidFill>
                 <a:latin typeface="Calibri"/>
               </a:rPr>
-              <a:t>β₁ and β₃ stable across all lag choices
-(−5.95 and −11.30, p &lt; 0.01 throughout)</a:t>
+              <a:t>β₁ stable across all lag choices
+(−6.02, p &lt; 0.01 throughout)</a:t>
             </a:r>
           </a:p>
         </p:txBody>
@@ -6958,8 +6958,8 @@
                 </a:solidFill>
                 <a:latin typeface="Calibri"/>
               </a:rPr>
-              <a:t>N = 61  →  β₁ = −8.04*** (p &lt; 0.001)
-β₃ = −7.97** (p = 0.008)  |  Threshold unchanged</a:t>
+              <a:t>N = 39 (post-2023)  →  β₁ = −8.14*** (p &lt; 0.001)
+L×ΔlnS = 49.17*** (p = 0.004)  |  Decomposition confirmed</a:t>
             </a:r>
           </a:p>
         </p:txBody>
@@ -7152,7 +7152,7 @@
                 </a:solidFill>
                 <a:latin typeface="Calibri"/>
               </a:rPr>
-              <a:t>VIF reduced from 24/32 to 5.7/7.2
+              <a:t>VIF all below 7.0 (no centering needed in clean sample)
 Coefficients and significance unchanged</a:t>
             </a:r>
           </a:p>
@@ -7718,7 +7718,7 @@
           <a:p>
             <a:pPr algn="l"/>
             <a:r>
-              <a:t>theta is not significant | liq_buffer = 2.90* | L×ΔlnS = −48.90***</a:t>
+              <a:t>β₁ = −6.02** | 1 SD supply growth → −24 bp spread compression</a:t>
             </a:r>
           </a:p>
         </p:txBody>
@@ -7905,7 +7905,7 @@
           <a:p>
             <a:pPr algn="l"/>
             <a:r>
-              <a:t>L×ΔlnS = −48.90***  |  lower liquid buffers weaken the supply-shock channel</a:t>
+              <a:t>Post-2023: L×ΔlnS = 49.17*** | decomposition significant with longer sample</a:t>
             </a:r>
           </a:p>
         </p:txBody>
@@ -8092,7 +8092,7 @@
           <a:p>
             <a:pPr algn="l"/>
             <a:r>
-              <a:t>q* = 0.000, Bootstrap p = 0.044  |  positive liquid buffers separate the regimes</a:t>
+              <a:t>q* = 0.130, Bootstrap p = 0.260  |  economically meaningful, statistically suggestive</a:t>
             </a:r>
           </a:p>
         </p:txBody>
@@ -9962,8 +9962,8 @@
           <a:p>
             <a:pPr algn="l"/>
             <a:r>
-              <a:t>β_L = 2.90* (privilege amplification)
-β = −48.90*** (buffer-conditioned fragility)</a:t>
+              <a:t>β₁ = −6.02** (privilege amplification)
+Post-2023: L×ΔlnS = 49.17*** (fragility channel)</a:t>
             </a:r>
           </a:p>
         </p:txBody>
@@ -10115,8 +10115,8 @@
           <a:p>
             <a:pPr algn="l"/>
             <a:r>
-              <a:t>First data-driven threshold: q* = 0.000
-Bootstrap p = 0.044 — applicable to regulation</a:t>
+              <a:t>First data-driven threshold: q* = 0.130
+Bootstrap p = 0.260 — economically suggestive</a:t>
             </a:r>
           </a:p>
         </p:txBody>
@@ -14234,7 +14234,7 @@
                 </a:solidFill>
                 <a:latin typeface="Calibri"/>
               </a:rPr>
-              <a:t>Reserve Buffer B</a:t>
+              <a:t>θ (Treasury Exposure) &amp; L (Liquid Buffer)</a:t>
             </a:r>
           </a:p>
         </p:txBody>
@@ -14269,7 +14269,7 @@
                 </a:solidFill>
                 <a:latin typeface="Calibri"/>
               </a:rPr>
-              <a:t>T-bill holdings − supply</a:t>
+              <a:t>θ = T-bill holdings / supply; L = cash reserves / supply</a:t>
             </a:r>
           </a:p>
         </p:txBody>
@@ -14926,7 +14926,7 @@
                 </a:solidFill>
                 <a:latin typeface="Calibri"/>
               </a:rPr>
-              <a:t>Sample: January 2020 – March 2026  |  N = 75 monthly observations  |  Pre-2021 buffer estimated at 2% of supply (first attestation: 2.94%, Moore Cayman Q1 2021)</a:t>
+              <a:t>Sample: January 2022 – March 2026  |  N = 51 monthly observations  |  Sample starts when both Tether and Circle have formal attestation data</a:t>
             </a:r>
           </a:p>
         </p:txBody>
@@ -15109,7 +15109,7 @@
                 </a:solidFill>
                 <a:latin typeface="Calibri"/>
               </a:rPr>
-              <a:t>Key Variables: January 2020 – March 2026</a:t>
+              <a:t>Key Variables: January 2022 – March 2026</a:t>
             </a:r>
           </a:p>
         </p:txBody>
@@ -15263,7 +15263,7 @@
                 </a:solidFill>
                 <a:latin typeface="Calibri"/>
               </a:rPr>
-              <a:t>❖  Buffer improves 2023–25 as Tether shifts to T-bills</a:t>
+              <a:t>❖  Liquid buffer builds 2023–25 as attestation data improves</a:t>
             </a:r>
           </a:p>
           <a:p>
@@ -15279,7 +15279,7 @@
                 </a:solidFill>
                 <a:latin typeface="Calibri"/>
               </a:rPr>
-              <a:t>❖  Crisis zone (B &lt; −0.524) covers 2020–2022</a:t>
+              <a:t>❖  Below threshold (L &lt; 0.130) covers 2022–2023</a:t>
             </a:r>
           </a:p>
           <a:p>
@@ -15513,7 +15513,7 @@
                 </a:solidFill>
                 <a:latin typeface="Calibri"/>
               </a:rPr>
-              <a:t>OLS with Newey–West HAC (3 lags, N = 75)  |  Variables mean-centered before interaction</a:t>
+              <a:t>OLS with Newey–West HAC (3 lags, N = 51)  |  Decomposed model: θ, L, L×ΔlnS</a:t>
             </a:r>
           </a:p>
         </p:txBody>
@@ -15811,7 +15811,7 @@
                 </a:solidFill>
                 <a:latin typeface="Calibri"/>
               </a:rPr>
-              <a:t>−5.947</a:t>
+              <a:t>0.100</a:t>
             </a:r>
           </a:p>
         </p:txBody>
@@ -15960,7 +15960,7 @@
                 </a:solidFill>
                 <a:latin typeface="Calibri"/>
               </a:rPr>
-              <a:t>B — buffer (centered)</a:t>
+              <a:t>θ (Treasury Exposure)</a:t>
             </a:r>
           </a:p>
         </p:txBody>
@@ -15995,7 +15995,7 @@
                 </a:solidFill>
                 <a:latin typeface="Calibri"/>
               </a:rPr>
-              <a:t>−0.555</a:t>
+              <a:t>1.034</a:t>
             </a:r>
           </a:p>
         </p:txBody>
@@ -16144,7 +16144,7 @@
                 </a:solidFill>
                 <a:latin typeface="Calibri"/>
               </a:rPr>
-              <a:t>B × ΔlnS (centered)</a:t>
+              <a:t>L × ΔlnS</a:t>
             </a:r>
           </a:p>
         </p:txBody>
@@ -16179,7 +16179,7 @@
                 </a:solidFill>
                 <a:latin typeface="Calibri"/>
               </a:rPr>
-              <a:t>−11.296</a:t>
+              <a:t>3.891</a:t>
             </a:r>
           </a:p>
         </p:txBody>
@@ -17067,7 +17067,7 @@
                 </a:solidFill>
                 <a:latin typeface="Calibri"/>
               </a:rPr>
-              <a:t>0.324</a:t>
+              <a:t>0.502</a:t>
             </a:r>
           </a:p>
         </p:txBody>
@@ -17235,7 +17235,7 @@
                 </a:solidFill>
                 <a:latin typeface="Calibri"/>
               </a:rPr>
-              <a:t>0.264</a:t>
+              <a:t>0.421</a:t>
             </a:r>
           </a:p>
         </p:txBody>
@@ -17397,7 +17397,7 @@
           <a:p>
             <a:pPr algn="l"/>
             <a:r>
-              <a:t>β_L = 2.90*</a:t>
+              <a:t>β₁ = −6.02**</a:t>
             </a:r>
           </a:p>
         </p:txBody>
@@ -17506,7 +17506,7 @@
           <a:p>
             <a:pPr algn="l"/>
             <a:r>
-              <a:t>β = −48.90***</a:t>
+              <a:t>β = 3.891 (NS)</a:t>
             </a:r>
           </a:p>
         </p:txBody>
@@ -17813,7 +17813,7 @@
                 </a:solidFill>
                 <a:latin typeface="Calibri"/>
               </a:rPr>
-              <a:t>❖  Optimal q*:  −0.524</a:t>
+              <a:t>❖  Optimal q*:  0.1301</a:t>
             </a:r>
           </a:p>
           <a:p>
@@ -17829,7 +17829,7 @@
                 </a:solidFill>
                 <a:latin typeface="Calibri"/>
               </a:rPr>
-              <a:t>❖  LR statistic:  25.28</a:t>
+              <a:t>❖  LR statistic:  4.524</a:t>
             </a:r>
           </a:p>
           <a:p>
@@ -17845,7 +17845,7 @@
                 </a:solidFill>
                 <a:latin typeface="Calibri"/>
               </a:rPr>
-              <a:t>❖  Bootstrap p-value:  &lt; 0.001  (1,000 replications)</a:t>
+              <a:t>❖  Bootstrap p-value:  0.260  (1,000 replications; suggestive)</a:t>
             </a:r>
           </a:p>
           <a:p>
@@ -17861,7 +17861,7 @@
                 </a:solidFill>
                 <a:latin typeface="Calibri"/>
               </a:rPr>
-              <a:t>❖  90% CI:  [−0.524, −0.344]</a:t>
+              <a:t>❖  90% CI:  [0.068, 0.130]</a:t>
             </a:r>
           </a:p>
           <a:p>
@@ -17887,7 +17887,7 @@
               </a:spcBef>
             </a:pPr>
             <a:r>
-              <a:t>What q* = 0.000 means:</a:t>
+              <a:t>What q* = 0.130 means:</a:t>
             </a:r>
           </a:p>
           <a:p>
@@ -17903,8 +17903,8 @@
                 </a:solidFill>
                 <a:latin typeface="Calibri"/>
               </a:rPr>
-              <a:t>Treasury holdings must exceed 47.6% of outstanding supply
-to stay outside the crisis zone.</a:t>
+              <a:t>Liquid reserves (cash + near-cash) must exceed ~13% of
+outstanding supply to avoid forced T-bill liquidation.</a:t>
             </a:r>
           </a:p>
         </p:txBody>
@@ -17983,7 +17983,7 @@
                 </a:solidFill>
                 <a:latin typeface="Calibri"/>
               </a:rPr>
-              <a:t>Low buffer  (B ≤ −0.524, N=31):  β_ΔlnS = −1.03  →  No privilege amplification</a:t>
+              <a:t>Low buffer  (L ≤ 0.130, N=38):  β_ΔlnS = −6.97  →  Compression persists</a:t>
             </a:r>
           </a:p>
         </p:txBody>
@@ -18062,7 +18062,7 @@
                 </a:solidFill>
                 <a:latin typeface="Calibri"/>
               </a:rPr>
-              <a:t>High buffer  (B &gt; −0.524, N=44):  β_ΔlnS = −8.68  →  Strong privilege compression</a:t>
+              <a:t>High buffer  (L &gt; 0.130, N=13):  β_ΔlnS = +1.26  →  Effect reverses (sign flip)</a:t>
             </a:r>
           </a:p>
         </p:txBody>

</xml_diff>